<commit_message>
20261007 commit : second-pjt start
</commit_message>
<xml_diff>
--- a/note_pad/linux/드론5th_D11_TBD_슬라이드2 (2).pptx
+++ b/note_pad/linux/드론5th_D11_TBD_슬라이드2 (2).pptx
@@ -6483,7 +6483,7 @@
           <a:p>
             <a:fld id="{5BCAD085-E8A6-8845-BD4E-CB4CCA059FC4}" type="datetimeFigureOut">
               <a:rPr lang="en-US" smtClean="0"/>
-              <a:t>10/2/2026</a:t>
+              <a:t>10/7/2026</a:t>
             </a:fld>
             <a:endParaRPr lang="en-US"/>
           </a:p>
@@ -6653,7 +6653,7 @@
           <a:p>
             <a:fld id="{5BCAD085-E8A6-8845-BD4E-CB4CCA059FC4}" type="datetimeFigureOut">
               <a:rPr lang="en-US" smtClean="0"/>
-              <a:t>10/2/2026</a:t>
+              <a:t>10/7/2026</a:t>
             </a:fld>
             <a:endParaRPr lang="en-US"/>
           </a:p>
@@ -6833,7 +6833,7 @@
           <a:p>
             <a:fld id="{5BCAD085-E8A6-8845-BD4E-CB4CCA059FC4}" type="datetimeFigureOut">
               <a:rPr lang="en-US" smtClean="0"/>
-              <a:t>10/2/2026</a:t>
+              <a:t>10/7/2026</a:t>
             </a:fld>
             <a:endParaRPr lang="en-US"/>
           </a:p>
@@ -7003,7 +7003,7 @@
           <a:p>
             <a:fld id="{5BCAD085-E8A6-8845-BD4E-CB4CCA059FC4}" type="datetimeFigureOut">
               <a:rPr lang="en-US" smtClean="0"/>
-              <a:t>10/2/2026</a:t>
+              <a:t>10/7/2026</a:t>
             </a:fld>
             <a:endParaRPr lang="en-US"/>
           </a:p>
@@ -7249,7 +7249,7 @@
           <a:p>
             <a:fld id="{5BCAD085-E8A6-8845-BD4E-CB4CCA059FC4}" type="datetimeFigureOut">
               <a:rPr lang="en-US" smtClean="0"/>
-              <a:t>10/2/2026</a:t>
+              <a:t>10/7/2026</a:t>
             </a:fld>
             <a:endParaRPr lang="en-US"/>
           </a:p>
@@ -7537,7 +7537,7 @@
           <a:p>
             <a:fld id="{5BCAD085-E8A6-8845-BD4E-CB4CCA059FC4}" type="datetimeFigureOut">
               <a:rPr lang="en-US" smtClean="0"/>
-              <a:t>10/2/2026</a:t>
+              <a:t>10/7/2026</a:t>
             </a:fld>
             <a:endParaRPr lang="en-US"/>
           </a:p>
@@ -7959,7 +7959,7 @@
           <a:p>
             <a:fld id="{5BCAD085-E8A6-8845-BD4E-CB4CCA059FC4}" type="datetimeFigureOut">
               <a:rPr lang="en-US" smtClean="0"/>
-              <a:t>10/2/2026</a:t>
+              <a:t>10/7/2026</a:t>
             </a:fld>
             <a:endParaRPr lang="en-US"/>
           </a:p>
@@ -8077,7 +8077,7 @@
           <a:p>
             <a:fld id="{5BCAD085-E8A6-8845-BD4E-CB4CCA059FC4}" type="datetimeFigureOut">
               <a:rPr lang="en-US" smtClean="0"/>
-              <a:t>10/2/2026</a:t>
+              <a:t>10/7/2026</a:t>
             </a:fld>
             <a:endParaRPr lang="en-US"/>
           </a:p>
@@ -8172,7 +8172,7 @@
           <a:p>
             <a:fld id="{5BCAD085-E8A6-8845-BD4E-CB4CCA059FC4}" type="datetimeFigureOut">
               <a:rPr lang="en-US" smtClean="0"/>
-              <a:t>10/2/2026</a:t>
+              <a:t>10/7/2026</a:t>
             </a:fld>
             <a:endParaRPr lang="en-US"/>
           </a:p>
@@ -8449,7 +8449,7 @@
           <a:p>
             <a:fld id="{5BCAD085-E8A6-8845-BD4E-CB4CCA059FC4}" type="datetimeFigureOut">
               <a:rPr lang="en-US" smtClean="0"/>
-              <a:t>10/2/2026</a:t>
+              <a:t>10/7/2026</a:t>
             </a:fld>
             <a:endParaRPr lang="en-US"/>
           </a:p>
@@ -8702,7 +8702,7 @@
           <a:p>
             <a:fld id="{5BCAD085-E8A6-8845-BD4E-CB4CCA059FC4}" type="datetimeFigureOut">
               <a:rPr lang="en-US" smtClean="0"/>
-              <a:t>10/2/2026</a:t>
+              <a:t>10/7/2026</a:t>
             </a:fld>
             <a:endParaRPr lang="en-US"/>
           </a:p>
@@ -8915,7 +8915,7 @@
           <a:p>
             <a:fld id="{5BCAD085-E8A6-8845-BD4E-CB4CCA059FC4}" type="datetimeFigureOut">
               <a:rPr lang="en-US" smtClean="0"/>
-              <a:t>10/2/2026</a:t>
+              <a:t>10/7/2026</a:t>
             </a:fld>
             <a:endParaRPr lang="en-US"/>
           </a:p>

</xml_diff>